<commit_message>
docs: rebuild the decks with the Brain Sauce name
Regenerated both decks from build-deck.js (pinned pptxgenjs 3.12.0 and the
pptx skill's apply_theme.js), so the title slide, footer, comparison table
column, revocation chart label and file title say Brain Sauce. Aspire's
challenge title on slide 1 and the speaker notes keep "The Internal Brain".

Apart from the rename, the slide XML and all 36 media files match the
previously committed decks (only docProps/core.xml timestamps differ). Both
decks pass the pptx skill's validate.py. Filenames are unchanged so existing
links keep working.

Co-Authored-By: Claude Opus 5.5 <noreply@anthropic.com>
</commit_message>
<xml_diff>
--- a/docs/presentations/internal-brain-architecture-submission.pptx
+++ b/docs/presentations/internal-brain-architecture-submission.pptx
@@ -120,21 +120,21 @@
   <p:extLst>
     <p:ext uri="{521415D9-36F7-43E2-AB2F-B90AF26B5E84}">
       <p14:sectionLst xmlns:p14="http://schemas.microsoft.com/office/powerpoint/2010/main">
-        <p14:section name="Story" id="{4f9aa0fe-2b25-c09c-8479-dc04c7d0e1ac}">
+        <p14:section name="Story" id="{ba0ae32a-e19f-0afa-1995-790b1cae7571}">
           <p14:sldIdLst>
             <p14:sldId id="256"/>
             <p14:sldId id="257"/>
             <p14:sldId id="258"/>
           </p14:sldIdLst>
         </p14:section>
-        <p14:section name="Architecture" id="{bbb6af53-5bab-408c-b06f-2c9e5f996278}">
+        <p14:section name="Architecture" id="{98ea6f4d-ca77-5fc4-2c4d-dae246164f83}">
           <p14:sldIdLst>
             <p14:sldId id="259"/>
             <p14:sldId id="260"/>
             <p14:sldId id="261"/>
           </p14:sldIdLst>
         </p14:section>
-        <p14:section name="Proof" id="{4764e9f5-cae3-f122-062f-e9a455d066fa}">
+        <p14:section name="Proof" id="{894a2809-f5d6-ca2f-ef68-4f27cfa74771}">
           <p14:sldIdLst>
             <p14:sldId id="262"/>
             <p14:sldId id="263"/>
@@ -272,7 +272,7 @@
                     <c:v>Gemini Enterprise, fastest identity sync</c:v>
                   </c:pt>
                   <c:pt idx="3">
-                    <c:v>Internal Brain, confidential documents</c:v>
+                    <c:v>Brain Sauce, confidential documents</c:v>
                   </c:pt>
                 </c:lvl>
               </c:multiLvlStrCache>
@@ -2210,7 +2210,7 @@
                   <a:schemeClr val="accent6"/>
                 </a:solidFill>
               </a:rPr>
-              <a:t>The Internal Brain  ·  Tencent Cloud AI CAN DO IT Hackathon SG 2026  ·  FinTech track, Aspire case study</a:t>
+              <a:t>Brain Sauce  ·  Tencent Cloud AI CAN DO IT Hackathon SG 2026  ·  FinTech track, Aspire case study</a:t>
             </a:r>
             <a:endParaRPr lang="en-US" sz="1000" dirty="0"/>
           </a:p>
@@ -2754,7 +2754,7 @@
                   <a:schemeClr val="bg1"/>
                 </a:solidFill>
               </a:rPr>
-              <a:t>The Internal Brain</a:t>
+              <a:t>Brain Sauce</a:t>
             </a:r>
             <a:endParaRPr lang="en-US" sz="5400" dirty="0"/>
           </a:p>
@@ -3816,7 +3816,7 @@
                             <a:schemeClr val="bg1"/>
                           </a:solidFill>
                         </a:rPr>
-                        <a:t>Internal Brain</a:t>
+                        <a:t>Brain Sauce</a:t>
                       </a:r>
                       <a:endParaRPr lang="en-US" sz="1200" dirty="0"/>
                     </a:p>
@@ -19387,9 +19387,9 @@
 </file>
 
 <file path=ppt/theme/theme1.xml><?xml version="1.0" encoding="utf-8"?>
-<a:theme xmlns:a="http://schemas.openxmlformats.org/drawingml/2006/main" name="Internal Brain">
+<a:theme xmlns:a="http://schemas.openxmlformats.org/drawingml/2006/main" name="Brain Sauce">
   <a:themeElements>
-    <a:clrScheme name="Internal Brain">
+    <a:clrScheme name="Brain Sauce">
       <a:dk1>
         <a:srgbClr val="0F172A"/>
       </a:dk1>
@@ -19427,7 +19427,7 @@
         <a:srgbClr val="7C5CD6"/>
       </a:folHlink>
     </a:clrScheme>
-    <a:fontScheme name="Internal Brain">
+    <a:fontScheme name="Brain Sauce">
       <a:majorFont>
         <a:latin typeface="Calibri"/>
         <a:ea typeface=""/>

</xml_diff>

<commit_message>
docs: mention the access map in the submission text and deck
Solution design describes the managers' access map (who can read each
document and why, capped by the viewer's own access, audited, revocation
removes the line live); the compliance impact ties it to periodic access
reviews; scenario 4 and slide 7 show John's line leaving the map.

Co-Authored-By: Claude Opus 5.5 <noreply@anthropic.com>
</commit_message>
<xml_diff>
--- a/docs/presentations/internal-brain-architecture-submission.pptx
+++ b/docs/presentations/internal-brain-architecture-submission.pptx
@@ -120,21 +120,21 @@
   <p:extLst>
     <p:ext uri="{521415D9-36F7-43E2-AB2F-B90AF26B5E84}">
       <p14:sectionLst xmlns:p14="http://schemas.microsoft.com/office/powerpoint/2010/main">
-        <p14:section name="Story" id="{1e71f93e-90c2-e0a9-612b-62b38a7a010a}">
+        <p14:section name="Story" id="{f3581d2c-f071-5ee3-f40d-7fba3bd089e6}">
           <p14:sldIdLst>
             <p14:sldId id="256"/>
             <p14:sldId id="257"/>
             <p14:sldId id="258"/>
           </p14:sldIdLst>
         </p14:section>
-        <p14:section name="Architecture" id="{137edd0d-3154-915a-fd71-3d58a1a63343}">
+        <p14:section name="Architecture" id="{2ec63568-ed19-f3d7-73ff-81b065201ccf}">
           <p14:sldIdLst>
             <p14:sldId id="259"/>
             <p14:sldId id="260"/>
             <p14:sldId id="261"/>
           </p14:sldIdLst>
         </p14:section>
-        <p14:section name="Proof" id="{146d3468-f03c-2e23-de42-699628e2df36}">
+        <p14:section name="Proof" id="{aafb7d34-8775-524a-3300-b0db38075808}">
           <p14:sldIdLst>
             <p14:sldId id="262"/>
             <p14:sldId id="263"/>
@@ -16599,7 +16599,7 @@
                   <a:schemeClr val="accent6"/>
                 </a:solidFill>
               </a:rPr>
-              <a:t>The saved answer is withheld too</a:t>
+              <a:t>Saved answer withheld; John's line leaves the access map</a:t>
             </a:r>
             <a:endParaRPr lang="en-US" sz="1300" dirty="0"/>
           </a:p>
@@ -16698,7 +16698,7 @@
                   <a:schemeClr val="accent6"/>
                 </a:solidFill>
               </a:rPr>
-              <a:t>Synthetic company and figures. Each scene is an automated test: test_ask_pipeline.py, test_permission_freshness.py and test_query_history_access.py.</a:t>
+              <a:t>Synthetic company and figures. Each scene is an automated test: test_ask_pipeline.py, test_permission_freshness.py, test_query_history_access.py and test_access_map.py.</a:t>
             </a:r>
             <a:endParaRPr lang="en-US" sz="1000" dirty="0"/>
           </a:p>

</xml_diff>

<commit_message>
docs: remove duplicate access-map sentence; deck test count 683
#23 and #26 both described the access map in scenario 4; keep one
sentence. The deck's numbers slide now matches main's 683 tests.

Co-Authored-By: Claude Opus 5.5 <noreply@anthropic.com>
</commit_message>
<xml_diff>
--- a/docs/presentations/internal-brain-architecture-submission.pptx
+++ b/docs/presentations/internal-brain-architecture-submission.pptx
@@ -120,21 +120,21 @@
   <p:extLst>
     <p:ext uri="{521415D9-36F7-43E2-AB2F-B90AF26B5E84}">
       <p14:sectionLst xmlns:p14="http://schemas.microsoft.com/office/powerpoint/2010/main">
-        <p14:section name="Story" id="{f3581d2c-f071-5ee3-f40d-7fba3bd089e6}">
+        <p14:section name="Story" id="{a132602a-7d26-2f69-59e5-80f0d432bef6}">
           <p14:sldIdLst>
             <p14:sldId id="256"/>
             <p14:sldId id="257"/>
             <p14:sldId id="258"/>
           </p14:sldIdLst>
         </p14:section>
-        <p14:section name="Architecture" id="{2ec63568-ed19-f3d7-73ff-81b065201ccf}">
+        <p14:section name="Architecture" id="{092b3cbe-1720-0b7b-68e7-afb15b4d3135}">
           <p14:sldIdLst>
             <p14:sldId id="259"/>
             <p14:sldId id="260"/>
             <p14:sldId id="261"/>
           </p14:sldIdLst>
         </p14:section>
-        <p14:section name="Proof" id="{aafb7d34-8775-524a-3300-b0db38075808}">
+        <p14:section name="Proof" id="{bc2af1c4-466d-3b41-ad5d-03e9b7d03fbe}">
           <p14:sldIdLst>
             <p14:sldId id="262"/>
             <p14:sldId id="263"/>
@@ -8287,7 +8287,7 @@
                   <a:schemeClr val="accent1"/>
                 </a:solidFill>
               </a:rPr>
-              <a:t>676</a:t>
+              <a:t>683</a:t>
             </a:r>
             <a:endParaRPr lang="en-US" sz="4800" dirty="0"/>
           </a:p>

</xml_diff>